<commit_message>
Improve guide quality and refresh prototype collateral
</commit_message>
<xml_diff>
--- a/docs/prototype-collateral/KCXDocumentor - Executive Pitch Deck.pptx
+++ b/docs/prototype-collateral/KCXDocumentor - Executive Pitch Deck.pptx
@@ -2484,7 +2484,7 @@
                 </a:solidFill>
                 <a:latin typeface="Roboto"/>
               </a:rPr>
-              <a:t>Built with the DamienDev presentation recipe pattern</a:t>
+              <a:t>Built with the KCX presentation standard</a:t>
             </a:r>
           </a:p>
         </p:txBody>
@@ -3645,7 +3645,7 @@
                 </a:solidFill>
                 <a:latin typeface="Roboto"/>
               </a:rPr>
-              <a:t>Rejected frames are excluded</a:t>
+              <a:t>Needs Attention frames are visible</a:t>
             </a:r>
           </a:p>
           <a:p>
@@ -3661,7 +3661,7 @@
                 </a:solidFill>
                 <a:latin typeface="Roboto"/>
               </a:rPr>
-              <a:t>Reviewer notes travel into generation context</a:t>
+              <a:t>Rejected frames are excluded</a:t>
             </a:r>
           </a:p>
           <a:p>
@@ -3677,7 +3677,7 @@
                 </a:solidFill>
                 <a:latin typeface="Roboto"/>
               </a:rPr>
-              <a:t>Comments identify areas needing validation</a:t>
+              <a:t>Reviewer notes travel into generation context</a:t>
             </a:r>
           </a:p>
         </p:txBody>
@@ -4030,6 +4030,22 @@
                 <a:latin typeface="Roboto"/>
               </a:rPr>
               <a:t>FFmpeg, Whisper, OCR, and frame extraction run locally</a:t>
+            </a:r>
+          </a:p>
+          <a:p>
+            <a:pPr>
+              <a:spcAft>
+                <a:spcPts val="500"/>
+              </a:spcAft>
+            </a:pPr>
+            <a:r>
+              <a:rPr sz="1050" b="0">
+                <a:solidFill>
+                  <a:srgbClr val="293436"/>
+                </a:solidFill>
+                <a:latin typeface="Roboto"/>
+              </a:rPr>
+              <a:t>Added video frames are OCR-enriched locally</a:t>
             </a:r>
           </a:p>
           <a:p>

</xml_diff>